<commit_message>
Add circular photo to slides
Co-authored-by: ayandhar0403 <55054321+ayandhar0403@users.noreply.github.com>
</commit_message>
<xml_diff>
--- a/EnergyWise-UK-Pitch-Deck.pptx
+++ b/EnergyWise-UK-Pitch-Deck.pptx
@@ -7317,14 +7317,58 @@
       </p:sp>
       <p:sp>
         <p:nvSpPr>
-          <p:cNvPr id="248" name="Text 245"/>
-          <p:cNvSpPr/>
-          <p:nvPr/>
-        </p:nvSpPr>
-        <p:spPr>
-          <a:xfrm>
-            <a:off x="1463040" y="3474720"/>
-            <a:ext cx="4572000" cy="365760"/>
+          <p:cNvPr id="248" name="Shape 245"/>
+          <p:cNvSpPr/>
+          <p:nvPr/>
+        </p:nvSpPr>
+        <p:spPr>
+          <a:xfrm>
+            <a:off x="1463040" y="3383280"/>
+            <a:ext cx="640080" cy="640080"/>
+          </a:xfrm>
+          <a:prstGeom prst="ellipse">
+            <a:avLst/>
+          </a:prstGeom>
+          <a:solidFill>
+            <a:srgbClr val="0D9488"/>
+          </a:solidFill>
+          <a:ln/>
+        </p:spPr>
+      </p:sp>
+      <p:pic>
+        <p:nvPicPr>
+          <p:cNvPr id="249" name="Image 1" descr="preencoded.png">    </p:cNvPr>
+          <p:cNvPicPr>
+            <a:picLocks noChangeAspect="1"/>
+          </p:cNvPicPr>
+          <p:nvPr/>
+        </p:nvPicPr>
+        <p:blipFill>
+          <a:blip r:embed="rId2"/>
+          <a:stretch>
+            <a:fillRect/>
+          </a:stretch>
+        </p:blipFill>
+        <p:spPr>
+          <a:xfrm>
+            <a:off x="1490472" y="3410712"/>
+            <a:ext cx="585216" cy="585216"/>
+          </a:xfrm>
+          <a:prstGeom prst="rect">
+            <a:avLst/>
+          </a:prstGeom>
+        </p:spPr>
+      </p:pic>
+      <p:sp>
+        <p:nvSpPr>
+          <p:cNvPr id="250" name="Text 246"/>
+          <p:cNvSpPr/>
+          <p:nvPr/>
+        </p:nvSpPr>
+        <p:spPr>
+          <a:xfrm>
+            <a:off x="2194560" y="3429000"/>
+            <a:ext cx="2743200" cy="274320"/>
           </a:xfrm>
           <a:prstGeom prst="rect">
             <a:avLst/>
@@ -7340,23 +7384,62 @@
               <a:buNone/>
             </a:pPr>
             <a:r>
-              <a:rPr lang="en-US" sz="1300" i="1" dirty="0">
+              <a:rPr lang="en-US" sz="1400" b="1" dirty="0">
                 <a:solidFill>
-                  <a:srgbClr val="64748B"/>
+                  <a:srgbClr val="FFFFFF"/>
+                </a:solidFill>
+                <a:latin typeface="Trebuchet MS" pitchFamily="34" charset="0"/>
+                <a:ea typeface="Trebuchet MS" pitchFamily="34" charset="-122"/>
+                <a:cs typeface="Trebuchet MS" pitchFamily="34" charset="-120"/>
+              </a:rPr>
+              <a:t>Ayan Dhar</a:t>
+            </a:r>
+            <a:endParaRPr lang="en-US" sz="1400" dirty="0"/>
+          </a:p>
+        </p:txBody>
+      </p:sp>
+      <p:sp>
+        <p:nvSpPr>
+          <p:cNvPr id="251" name="Text 247"/>
+          <p:cNvSpPr/>
+          <p:nvPr/>
+        </p:nvSpPr>
+        <p:spPr>
+          <a:xfrm>
+            <a:off x="2194560" y="3703320"/>
+            <a:ext cx="3657600" cy="228600"/>
+          </a:xfrm>
+          <a:prstGeom prst="rect">
+            <a:avLst/>
+          </a:prstGeom>
+          <a:noFill/>
+          <a:ln/>
+        </p:spPr>
+        <p:txBody>
+          <a:bodyPr wrap="square" lIns="0" tIns="0" rIns="0" bIns="0" rtlCol="0" anchor="ctr"/>
+          <a:lstStyle/>
+          <a:p>
+            <a:pPr indent="0" marL="0">
+              <a:buNone/>
+            </a:pPr>
+            <a:r>
+              <a:rPr lang="en-US" sz="1000" dirty="0">
+                <a:solidFill>
+                  <a:srgbClr val="94A3B8"/>
                 </a:solidFill>
                 <a:latin typeface="Calibri" pitchFamily="34" charset="0"/>
                 <a:ea typeface="Calibri" pitchFamily="34" charset="-122"/>
                 <a:cs typeface="Calibri" pitchFamily="34" charset="-120"/>
               </a:rPr>
-              <a:t>Presented by Ayan Dhar</a:t>
+              <a:t>MSc Data Science &amp; Analytics | Cardiff University</a:t>
             </a:r>
-            <a:endParaRPr lang="en-US" sz="1300" dirty="0"/>
+            <a:endParaRPr lang="en-US" sz="1000" dirty="0"/>
           </a:p>
         </p:txBody>
       </p:sp>
       <p:sp>
         <p:nvSpPr>
-          <p:cNvPr id="249" name="Shape 246"/>
+          <p:cNvPr id="252" name="Shape 248"/>
           <p:cNvSpPr/>
           <p:nvPr/>
         </p:nvSpPr>
@@ -20247,55 +20330,38 @@
             <a:avLst/>
           </a:prstGeom>
           <a:solidFill>
-            <a:srgbClr val="0D9488">
-              <a:alpha val="50000"/>
-            </a:srgbClr>
-          </a:solidFill>
-          <a:ln/>
-        </p:spPr>
-      </p:sp>
-      <p:sp>
-        <p:nvSpPr>
-          <p:cNvPr id="7" name="Text 4"/>
-          <p:cNvSpPr/>
-          <p:nvPr/>
-        </p:nvSpPr>
-        <p:spPr>
-          <a:xfrm>
-            <a:off x="1828800" y="1600200"/>
-            <a:ext cx="1097280" cy="822960"/>
+            <a:srgbClr val="0D9488"/>
+          </a:solidFill>
+          <a:ln/>
+        </p:spPr>
+      </p:sp>
+      <p:pic>
+        <p:nvPicPr>
+          <p:cNvPr id="7" name="Image 1" descr="preencoded.png">    </p:cNvPr>
+          <p:cNvPicPr>
+            <a:picLocks noChangeAspect="1"/>
+          </p:cNvPicPr>
+          <p:nvPr/>
+        </p:nvPicPr>
+        <p:blipFill>
+          <a:blip r:embed="rId2"/>
+          <a:stretch>
+            <a:fillRect/>
+          </a:stretch>
+        </p:blipFill>
+        <p:spPr>
+          <a:xfrm>
+            <a:off x="1856232" y="1490472"/>
+            <a:ext cx="1042416" cy="1042416"/>
           </a:xfrm>
           <a:prstGeom prst="rect">
             <a:avLst/>
           </a:prstGeom>
-          <a:noFill/>
-          <a:ln/>
-        </p:spPr>
-        <p:txBody>
-          <a:bodyPr wrap="square" lIns="0" tIns="0" rIns="0" bIns="0" rtlCol="0" anchor="ctr"/>
-          <a:lstStyle/>
-          <a:p>
-            <a:pPr algn="ctr" indent="0" marL="0">
-              <a:buNone/>
-            </a:pPr>
-            <a:r>
-              <a:rPr lang="en-US" sz="2800" b="1" dirty="0">
-                <a:solidFill>
-                  <a:srgbClr val="FFFFFF"/>
-                </a:solidFill>
-                <a:latin typeface="Trebuchet MS" pitchFamily="34" charset="0"/>
-                <a:ea typeface="Trebuchet MS" pitchFamily="34" charset="-122"/>
-                <a:cs typeface="Trebuchet MS" pitchFamily="34" charset="-120"/>
-              </a:rPr>
-              <a:t>AD</a:t>
-            </a:r>
-            <a:endParaRPr lang="en-US" sz="2800" dirty="0"/>
-          </a:p>
-        </p:txBody>
-      </p:sp>
-      <p:sp>
-        <p:nvSpPr>
-          <p:cNvPr id="8" name="Text 5"/>
+        </p:spPr>
+      </p:pic>
+      <p:sp>
+        <p:nvSpPr>
+          <p:cNvPr id="8" name="Text 4"/>
           <p:cNvSpPr/>
           <p:nvPr/>
         </p:nvSpPr>
@@ -20334,7 +20400,7 @@
       </p:sp>
       <p:sp>
         <p:nvSpPr>
-          <p:cNvPr id="9" name="Text 6"/>
+          <p:cNvPr id="9" name="Text 5"/>
           <p:cNvSpPr/>
           <p:nvPr/>
         </p:nvSpPr>
@@ -20373,7 +20439,7 @@
       </p:sp>
       <p:sp>
         <p:nvSpPr>
-          <p:cNvPr id="10" name="Text 7"/>
+          <p:cNvPr id="10" name="Text 6"/>
           <p:cNvSpPr/>
           <p:nvPr/>
         </p:nvSpPr>
@@ -20533,7 +20599,7 @@
       </p:sp>
       <p:sp>
         <p:nvSpPr>
-          <p:cNvPr id="11" name="Text 8"/>
+          <p:cNvPr id="11" name="Text 7"/>
           <p:cNvSpPr/>
           <p:nvPr/>
         </p:nvSpPr>

</xml_diff>

<commit_message>
Move name and photo to slide 9
Co-authored-by: ayandhar0403 <55054321+ayandhar0403@users.noreply.github.com>
</commit_message>
<xml_diff>
--- a/EnergyWise-UK-Pitch-Deck.pptx
+++ b/EnergyWise-UK-Pitch-Deck.pptx
@@ -7317,58 +7317,14 @@
       </p:sp>
       <p:sp>
         <p:nvSpPr>
-          <p:cNvPr id="248" name="Shape 245"/>
-          <p:cNvSpPr/>
-          <p:nvPr/>
-        </p:nvSpPr>
-        <p:spPr>
-          <a:xfrm>
-            <a:off x="1463040" y="3383280"/>
-            <a:ext cx="640080" cy="640080"/>
-          </a:xfrm>
-          <a:prstGeom prst="ellipse">
-            <a:avLst/>
-          </a:prstGeom>
-          <a:solidFill>
-            <a:srgbClr val="0D9488"/>
-          </a:solidFill>
-          <a:ln/>
-        </p:spPr>
-      </p:sp>
-      <p:pic>
-        <p:nvPicPr>
-          <p:cNvPr id="249" name="Image 1" descr="preencoded.png">    </p:cNvPr>
-          <p:cNvPicPr>
-            <a:picLocks noChangeAspect="1"/>
-          </p:cNvPicPr>
-          <p:nvPr/>
-        </p:nvPicPr>
-        <p:blipFill>
-          <a:blip r:embed="rId2"/>
-          <a:stretch>
-            <a:fillRect/>
-          </a:stretch>
-        </p:blipFill>
-        <p:spPr>
-          <a:xfrm>
-            <a:off x="1490472" y="3410712"/>
-            <a:ext cx="585216" cy="585216"/>
-          </a:xfrm>
-          <a:prstGeom prst="rect">
-            <a:avLst/>
-          </a:prstGeom>
-        </p:spPr>
-      </p:pic>
-      <p:sp>
-        <p:nvSpPr>
-          <p:cNvPr id="250" name="Text 246"/>
-          <p:cNvSpPr/>
-          <p:nvPr/>
-        </p:nvSpPr>
-        <p:spPr>
-          <a:xfrm>
-            <a:off x="2194560" y="3429000"/>
-            <a:ext cx="2743200" cy="274320"/>
+          <p:cNvPr id="248" name="Text 245"/>
+          <p:cNvSpPr/>
+          <p:nvPr/>
+        </p:nvSpPr>
+        <p:spPr>
+          <a:xfrm>
+            <a:off x="1463040" y="3474720"/>
+            <a:ext cx="4572000" cy="365760"/>
           </a:xfrm>
           <a:prstGeom prst="rect">
             <a:avLst/>
@@ -7384,62 +7340,23 @@
               <a:buNone/>
             </a:pPr>
             <a:r>
-              <a:rPr lang="en-US" sz="1400" b="1" dirty="0">
+              <a:rPr lang="en-US" sz="1300" i="1" dirty="0">
                 <a:solidFill>
-                  <a:srgbClr val="FFFFFF"/>
-                </a:solidFill>
-                <a:latin typeface="Trebuchet MS" pitchFamily="34" charset="0"/>
-                <a:ea typeface="Trebuchet MS" pitchFamily="34" charset="-122"/>
-                <a:cs typeface="Trebuchet MS" pitchFamily="34" charset="-120"/>
-              </a:rPr>
-              <a:t>Ayan Dhar</a:t>
-            </a:r>
-            <a:endParaRPr lang="en-US" sz="1400" dirty="0"/>
-          </a:p>
-        </p:txBody>
-      </p:sp>
-      <p:sp>
-        <p:nvSpPr>
-          <p:cNvPr id="251" name="Text 247"/>
-          <p:cNvSpPr/>
-          <p:nvPr/>
-        </p:nvSpPr>
-        <p:spPr>
-          <a:xfrm>
-            <a:off x="2194560" y="3703320"/>
-            <a:ext cx="3657600" cy="228600"/>
-          </a:xfrm>
-          <a:prstGeom prst="rect">
-            <a:avLst/>
-          </a:prstGeom>
-          <a:noFill/>
-          <a:ln/>
-        </p:spPr>
-        <p:txBody>
-          <a:bodyPr wrap="square" lIns="0" tIns="0" rIns="0" bIns="0" rtlCol="0" anchor="ctr"/>
-          <a:lstStyle/>
-          <a:p>
-            <a:pPr indent="0" marL="0">
-              <a:buNone/>
-            </a:pPr>
-            <a:r>
-              <a:rPr lang="en-US" sz="1000" dirty="0">
-                <a:solidFill>
-                  <a:srgbClr val="94A3B8"/>
+                  <a:srgbClr val="64748B"/>
                 </a:solidFill>
                 <a:latin typeface="Calibri" pitchFamily="34" charset="0"/>
                 <a:ea typeface="Calibri" pitchFamily="34" charset="-122"/>
                 <a:cs typeface="Calibri" pitchFamily="34" charset="-120"/>
               </a:rPr>
-              <a:t>MSc Data Science &amp; Analytics | Cardiff University</a:t>
+              <a:t>Presented by Ayan Dhar</a:t>
             </a:r>
-            <a:endParaRPr lang="en-US" sz="1000" dirty="0"/>
+            <a:endParaRPr lang="en-US" sz="1300" dirty="0"/>
           </a:p>
         </p:txBody>
       </p:sp>
       <p:sp>
         <p:nvSpPr>
-          <p:cNvPr id="252" name="Shape 248"/>
+          <p:cNvPr id="249" name="Shape 246"/>
           <p:cNvSpPr/>
           <p:nvPr/>
         </p:nvSpPr>

</xml_diff>

<commit_message>
Fix slide 4 text overlap
Co-authored-by: ayandhar0403 <55054321+ayandhar0403@users.noreply.github.com>
</commit_message>
<xml_diff>
--- a/EnergyWise-UK-Pitch-Deck.pptx
+++ b/EnergyWise-UK-Pitch-Deck.pptx
@@ -16902,8 +16902,8 @@
         </p:nvSpPr>
         <p:spPr>
           <a:xfrm>
-            <a:off x="914400" y="1051560"/>
-            <a:ext cx="7315200" cy="1005840"/>
+            <a:off x="457200" y="1051560"/>
+            <a:ext cx="8229600" cy="914400"/>
           </a:xfrm>
           <a:prstGeom prst="rect">
             <a:avLst/>
@@ -16924,8 +16924,8 @@
         </p:nvSpPr>
         <p:spPr>
           <a:xfrm>
-            <a:off x="1097280" y="1143000"/>
-            <a:ext cx="914400" cy="365760"/>
+            <a:off x="731520" y="1143000"/>
+            <a:ext cx="914400" cy="320040"/>
           </a:xfrm>
           <a:prstGeom prst="rect">
             <a:avLst/>
@@ -16963,7 +16963,7 @@
         </p:nvSpPr>
         <p:spPr>
           <a:xfrm>
-            <a:off x="1097280" y="1417320"/>
+            <a:off x="731520" y="1417320"/>
             <a:ext cx="1828800" cy="457200"/>
           </a:xfrm>
           <a:prstGeom prst="rect">
@@ -17002,8 +17002,8 @@
         </p:nvSpPr>
         <p:spPr>
           <a:xfrm>
-            <a:off x="3200400" y="1325880"/>
-            <a:ext cx="4572000" cy="457200"/>
+            <a:off x="3017520" y="1280160"/>
+            <a:ext cx="5212080" cy="457200"/>
           </a:xfrm>
           <a:prstGeom prst="rect">
             <a:avLst/>
@@ -17041,8 +17041,8 @@
         </p:nvSpPr>
         <p:spPr>
           <a:xfrm>
-            <a:off x="2057400" y="2286000"/>
-            <a:ext cx="5029200" cy="1005840"/>
+            <a:off x="457200" y="2194560"/>
+            <a:ext cx="6400800" cy="914400"/>
           </a:xfrm>
           <a:prstGeom prst="rect">
             <a:avLst/>
@@ -17063,8 +17063,8 @@
         </p:nvSpPr>
         <p:spPr>
           <a:xfrm>
-            <a:off x="2240280" y="2377440"/>
-            <a:ext cx="914400" cy="365760"/>
+            <a:off x="731520" y="2286000"/>
+            <a:ext cx="914400" cy="320040"/>
           </a:xfrm>
           <a:prstGeom prst="rect">
             <a:avLst/>
@@ -17102,7 +17102,7 @@
         </p:nvSpPr>
         <p:spPr>
           <a:xfrm>
-            <a:off x="2240280" y="2651760"/>
+            <a:off x="731520" y="2560320"/>
             <a:ext cx="1828800" cy="457200"/>
           </a:xfrm>
           <a:prstGeom prst="rect">
@@ -17141,8 +17141,8 @@
         </p:nvSpPr>
         <p:spPr>
           <a:xfrm>
-            <a:off x="4343400" y="2560320"/>
-            <a:ext cx="2286000" cy="457200"/>
+            <a:off x="3017520" y="2423160"/>
+            <a:ext cx="3383280" cy="457200"/>
           </a:xfrm>
           <a:prstGeom prst="rect">
             <a:avLst/>
@@ -17180,8 +17180,8 @@
         </p:nvSpPr>
         <p:spPr>
           <a:xfrm>
-            <a:off x="3200400" y="3520440"/>
-            <a:ext cx="2743200" cy="1005840"/>
+            <a:off x="457200" y="3337560"/>
+            <a:ext cx="4572000" cy="914400"/>
           </a:xfrm>
           <a:prstGeom prst="rect">
             <a:avLst/>
@@ -17202,8 +17202,8 @@
         </p:nvSpPr>
         <p:spPr>
           <a:xfrm>
-            <a:off x="3383280" y="3611880"/>
-            <a:ext cx="914400" cy="365760"/>
+            <a:off x="731520" y="3429000"/>
+            <a:ext cx="914400" cy="320040"/>
           </a:xfrm>
           <a:prstGeom prst="rect">
             <a:avLst/>
@@ -17241,7 +17241,7 @@
         </p:nvSpPr>
         <p:spPr>
           <a:xfrm>
-            <a:off x="3383280" y="3886200"/>
+            <a:off x="731520" y="3703320"/>
             <a:ext cx="1828800" cy="457200"/>
           </a:xfrm>
           <a:prstGeom prst="rect">
@@ -17280,8 +17280,8 @@
         </p:nvSpPr>
         <p:spPr>
           <a:xfrm>
-            <a:off x="5486400" y="3794760"/>
-            <a:ext cx="0" cy="457200"/>
+            <a:off x="3017520" y="3566160"/>
+            <a:ext cx="1554480" cy="457200"/>
           </a:xfrm>
           <a:prstGeom prst="rect">
             <a:avLst/>

</xml_diff>